<commit_message>
Fix Show images that failed to load.
Replace transparent PNGs with RGB JPEGs, rebuild the PPTX, and add
a zip so Zoho Show and GitHub do not have to preview the old files.

Co-authored-by: JuliaSan09 <JuliaSan09@users.noreply.github.com>
</commit_message>
<xml_diff>
--- a/docs/ekya-admissions/show/Ekya-CMR-Admissions-Demo.pptx
+++ b/docs/ekya-admissions/show/Ekya-CMR-Admissions-Demo.pptx
@@ -6609,7 +6609,7 @@
       </p:sp>
       <p:pic>
         <p:nvPicPr>
-          <p:cNvPr id="7" name="Picture 6" descr="08-enquiry-forms-inbound-phone.png"/>
+          <p:cNvPr id="7" name="Picture 6" descr="11-sop-forms-inbound.jpg"/>
           <p:cNvPicPr>
             <a:picLocks noChangeAspect="1"/>
           </p:cNvPicPr>
@@ -6623,8 +6623,8 @@
         </p:blipFill>
         <p:spPr>
           <a:xfrm>
-            <a:off x="3286577" y="1298448"/>
-            <a:ext cx="5588366" cy="4937760"/>
+            <a:off x="3286555" y="1298448"/>
+            <a:ext cx="5588410" cy="4937760"/>
           </a:xfrm>
           <a:prstGeom prst="rect">
             <a:avLst/>
@@ -7603,7 +7603,7 @@
       </p:sp>
       <p:pic>
         <p:nvPicPr>
-          <p:cNvPr id="7" name="Picture 6" descr="07-campus-visit-email-whatsapp.png"/>
+          <p:cNvPr id="7" name="Picture 6" descr="13-sop-campus-visit.jpg"/>
           <p:cNvPicPr>
             <a:picLocks noChangeAspect="1"/>
           </p:cNvPicPr>
@@ -11489,7 +11489,7 @@
       </p:sp>
       <p:pic>
         <p:nvPicPr>
-          <p:cNvPr id="7" name="Picture 6" descr="04-lead-quality-telephony-portal.png"/>
+          <p:cNvPr id="7" name="Picture 6" descr="18-sop-portal-telephony.jpg"/>
           <p:cNvPicPr>
             <a:picLocks noChangeAspect="1"/>
           </p:cNvPicPr>
@@ -11503,8 +11503,8 @@
         </p:blipFill>
         <p:spPr>
           <a:xfrm>
-            <a:off x="3265551" y="1298448"/>
-            <a:ext cx="5630418" cy="4937760"/>
+            <a:off x="3263782" y="1298448"/>
+            <a:ext cx="5633955" cy="4937760"/>
           </a:xfrm>
           <a:prstGeom prst="rect">
             <a:avLst/>
@@ -16843,7 +16843,7 @@
       </p:sp>
       <p:pic>
         <p:nvPicPr>
-          <p:cNvPr id="7" name="Picture 6" descr="05-lead-mgmt-usecases-reports.png"/>
+          <p:cNvPr id="7" name="Picture 6" descr="21-sop-reports.jpg"/>
           <p:cNvPicPr>
             <a:picLocks noChangeAspect="1"/>
           </p:cNvPicPr>
@@ -16857,8 +16857,8 @@
         </p:blipFill>
         <p:spPr>
           <a:xfrm>
-            <a:off x="3298588" y="1298448"/>
-            <a:ext cx="5564344" cy="4937760"/>
+            <a:off x="3297803" y="1298448"/>
+            <a:ext cx="5565913" cy="4937760"/>
           </a:xfrm>
           <a:prstGeom prst="rect">
             <a:avLst/>
@@ -19568,7 +19568,7 @@
       </p:sp>
       <p:pic>
         <p:nvPicPr>
-          <p:cNvPr id="7" name="Picture 6" descr="03-brands-campuses-stages.png"/>
+          <p:cNvPr id="7" name="Picture 6" descr="05-sop-brands-campuses.jpg"/>
           <p:cNvPicPr>
             <a:picLocks noChangeAspect="1"/>
           </p:cNvPicPr>
@@ -19582,8 +19582,8 @@
         </p:blipFill>
         <p:spPr>
           <a:xfrm>
-            <a:off x="3259671" y="1298448"/>
-            <a:ext cx="5642177" cy="4937760"/>
+            <a:off x="3259183" y="1298448"/>
+            <a:ext cx="5643154" cy="4937760"/>
           </a:xfrm>
           <a:prstGeom prst="rect">
             <a:avLst/>

</xml_diff>